<commit_message>
docs: atualizar slides 4 e 7, README e declaracao de uso de IA
Slides 4 e 7 com a sonda e a medicao do notebook e do POCO X5 Pro 5G, notas do apresentador atualizadas e painel real do notebook. README com aparelhos onde o ambiente funcionou, limitacoes revistas e uso de IA. Especificacao com a medicao na Secao 10 e o uso de IA no registro do Modulo 03.
</commit_message>
<xml_diff>
--- a/grupo01_modulo03.pptx
+++ b/grupo01_modulo03.pptx
@@ -448,7 +448,7 @@
           <a:lstStyle xmlns:a="http://schemas.openxmlformats.org/drawingml/2006/main"/>
           <a:p xmlns:a="http://schemas.openxmlformats.org/drawingml/2006/main">
             <a:r>
-              <a:t>Grupo 1. Cena: bateria acústica. Integrantes conforme docs/especificacao.md, seção 1. Fonte da imagem: docs/evidencias/cena-slide.png, captura real da aplicação. A etiqueta local da entrega é modulo-03; a publicação remota ainda depende da autenticação do grupo.</a:t>
+              <a:t>Grupo 1. Cena: bateria acústica. Integrantes conforme docs/especificacao.md, seção 1. Fonte da imagem: docs/evidencias/cena-slide.png, captura real da aplicação. A etiqueta da entrega é modulo-03, criada depois do último commit.</a:t>
             </a:r>
           </a:p>
         </p:txBody>
@@ -658,7 +658,7 @@
           <a:lstStyle xmlns:a="http://schemas.openxmlformats.org/drawingml/2006/main"/>
           <a:p xmlns:a="http://schemas.openxmlformats.org/drawingml/2006/main">
             <a:r>
-              <a:t>A consulta é real. isSessionSupported pergunta pelos modos; requestSession consulta recursos, espaços, entradas e poses. A falta de um item em enabledFeatures não distingue, sozinha, hardware ausente e autorização negada. Não inventamos essa causa. navigator.xr ausente e erros de permissão da sessão têm mensagens próprias. No container, inline foi suportado e os dois modos imersivos não. Falta repetir o mesmo endereço em um celular ou visor físico, e isso consta no slide 7. Fonte: docs/evidencias/sonda-desktop.txt e https://www.w3.org/TR/webxr/.</a:t>
+              <a:t>A consulta é real. isSessionSupported pergunta pelos modos; requestSession consulta recursos, espaços, entradas e poses. A falta de um item em enabledFeatures não distingue, sozinha, hardware ausente e autorização negada. Não inventamos essa causa. navigator.xr ausente e erros de permissão da sessão têm mensagens próprias. No notebook (Dell Inspiron 15, Chrome 153), só a janela foi suportada. No POCO X5 Pro 5G (Android 14, Chrome 153), janela, VR e AR foram declarados; a sessão immersive-ar concedeu local-floor, unbounded, hit-test, anchors e plane-detection, com seis graus de liberdade. Não concedidos: bounded-floor, hand-tracking e dom-overlay (a sonda não informa o root que o dom-overlay exige). A sonda rotula o celular como visor porque só reconhece aparelho de mão com AR sem VR; a correção foi adiada e consta no slide 7. Uma primeira sondagem do notebook foi descartada: o Immersive Web Emulator declarou VR, AR e controles de Quest 3. Fonte: docs/aparelhos.md, docs/evidencias/sonda-pc.png, docs/evidencias/sonda-celular-*.jpg e https://www.w3.org/TR/webxr/.</a:t>
             </a:r>
           </a:p>
         </p:txBody>
@@ -868,7 +868,7 @@
           <a:lstStyle xmlns:a="http://schemas.openxmlformats.org/drawingml/2006/main"/>
           <a:p xmlns:a="http://schemas.openxmlformats.org/drawingml/2006/main">
             <a:r>
-              <a:t>CPU: 0.7441666666961585 ms. Intervalo: 30.83285 ms. Teto: 16.666666666666668 ms. Máquina, navegador e viewport integrais em docs/evidencias/browser.json. A CPU mede trabalho do callback até o retorno de render, não o tempo completo da GPU. O intervalo alto é uma limitação do resultado obtido e não prova desempenho nos aparelhos do grupo. O teste numérico de 30, 60 e 144 FPS verifica a fórmula de tempo; a comparação física continua pendente. Também pendem publicação remota da etiqueta modulo-03, sonda em duas classes, execução por alguém de fora e ensaio de cada integrante em um slide alheio. Montagem completa, alcance sentado e VR/AR da bateria pertencem aos módulos seguintes.</a:t>
+              <a:t>Notebook Dell Inspiron 15 3530 (i5-1334U, Iris Xe, Windows 11, Chrome 153, tela de 60 Hz): CPU 1.097499993443489 ms, intervalo 16.667499999999805 ms. Celular POCO X5 Pro 5G (Android 14, Chrome 153): CPU 0.5574999908606212 ms, intervalo 16.358333333333334 ms. Teto: 16.666666666666668 ms. Médias de 120 quadros; dados integrais em docs/evidencias/medicao-pc.json e medicao-celular.json. A captura do painel é outro instante da mesma execução no notebook. A CPU mede trabalho do callback até o retorno de render, não o tempo completo da GPU. No notebook o intervalo coincide com o teto porque o navegador desenha no ritmo da tela de 60 Hz: não é folga medida. No celular a média ficou abaixo do teto, com quadros isolados acima. O teste numérico de 30, 60 e 144 FPS verifica a fórmula de tempo. Pendem a etiqueta modulo-03, a correção da classe do celular na sonda, a execução por alguém de fora e o ensaio de cada integrante em um slide alheio. Montagem completa, alcance sentado e VR/AR da bateria pertencem aos módulos seguintes.</a:t>
             </a:r>
           </a:p>
         </p:txBody>
@@ -4604,7 +4604,7 @@
                           <a:ea typeface="Nimbus Sans"/>
                           <a:cs typeface="Nimbus Sans"/>
                         </a:rPr>
-                        <a:t>Chromium no container</a:t>
+                        <a:t>Notebook (Windows, Chrome 153)</a:t>
                       </a:r>
                     </a:p>
                   </a:txBody>
@@ -4678,7 +4678,7 @@
                           <a:ea typeface="Nimbus Sans"/>
                           <a:cs typeface="Nimbus Sans"/>
                         </a:rPr>
-                        <a:t>Celular físico</a:t>
+                        <a:t>POCO X5 Pro 5G (Android 14)</a:t>
                       </a:r>
                     </a:p>
                   </a:txBody>
@@ -4702,7 +4702,7 @@
                           <a:ea typeface="Nimbus Sans"/>
                           <a:cs typeface="Nimbus Sans"/>
                         </a:rPr>
-                        <a:t>Pendente</a:t>
+                        <a:t>Abriu</a:t>
                       </a:r>
                     </a:p>
                   </a:txBody>
@@ -4726,7 +4726,7 @@
                           <a:ea typeface="Nimbus Sans"/>
                           <a:cs typeface="Nimbus Sans"/>
                         </a:rPr>
-                        <a:t>Pendente</a:t>
+                        <a:t>Declarados; AR abriu</a:t>
                       </a:r>
                     </a:p>
                   </a:txBody>
@@ -4850,7 +4850,7 @@
                 <a:ea typeface="Nimbus Sans"/>
                 <a:cs typeface="Nimbus Sans"/>
               </a:rPr>
-              <a:t>ts/src/bancada/{modes/verificacao.ts, devices/sonda.ts}; docs/evidencias/sonda-desktop.txt</a:t>
+              <a:t>ts/src/bancada/{modes/verificacao.ts, devices/sonda.ts}; docs/evidencias/{sonda-pc.png, sonda-celular-*.jpg}</a:t>
             </a:r>
           </a:p>
         </p:txBody>
@@ -7170,7 +7170,7 @@
                 <a:ea typeface="Nimbus Sans"/>
                 <a:cs typeface="Nimbus Sans"/>
               </a:rPr>
-              <a:t>0,74 ms</a:t>
+              <a:t>1,10 ms</a:t>
             </a:r>
           </a:p>
         </p:txBody>
@@ -7227,7 +7227,7 @@
                 <a:ea typeface="Nimbus Sans"/>
                 <a:cs typeface="Nimbus Sans"/>
               </a:rPr>
-              <a:t>Intervalo 30,83 ms</a:t>
+              <a:t>Intervalo 16,67 ms</a:t>
             </a:r>
           </a:p>
           <a:p xmlns:a="http://schemas.openxmlformats.org/drawingml/2006/main">
@@ -7375,7 +7375,7 @@
                 <a:ea typeface="Nimbus Sans"/>
                 <a:cs typeface="Nimbus Sans"/>
               </a:rPr>
-              <a:t>Linux, AMD EPYC 9V74.</a:t>
+              <a:t>Notebook Dell Inspiron 15,</a:t>
             </a:r>
           </a:p>
           <a:p xmlns:a="http://schemas.openxmlformats.org/drawingml/2006/main">
@@ -7398,7 +7398,7 @@
                 <a:ea typeface="Nimbus Sans"/>
                 <a:cs typeface="Nimbus Sans"/>
               </a:rPr>
-              <a:t>Chromium 134, SwiftShader</a:t>
+              <a:t>i5-1334U, Iris Xe,</a:t>
             </a:r>
           </a:p>
           <a:p xmlns:a="http://schemas.openxmlformats.org/drawingml/2006/main">
@@ -7421,7 +7421,7 @@
                 <a:ea typeface="Nimbus Sans"/>
                 <a:cs typeface="Nimbus Sans"/>
               </a:rPr>
-              <a:t>(renderização por software).</a:t>
+              <a:t>Chrome 153, tela de 60 Hz.</a:t>
             </a:r>
           </a:p>
         </p:txBody>
@@ -7535,7 +7535,7 @@
                 <a:ea typeface="Nimbus Sans"/>
                 <a:cs typeface="Nimbus Sans"/>
               </a:rPr>
-              <a:t>Medição registrada no JSON</a:t>
+              <a:t>Celular POCO X5 Pro: 0,56 / 16,36 ms</a:t>
             </a:r>
           </a:p>
         </p:txBody>
@@ -7649,7 +7649,7 @@
                 <a:ea typeface="Nimbus Sans"/>
                 <a:cs typeface="Nimbus Sans"/>
               </a:rPr>
-              <a:t>Publicar a etiqueta; medir e consultar a sonda em duas classes de aparelho.</a:t>
+              <a:t>Publicar a etiqueta; sonda rotula o celular como visor (correção adiada).</a:t>
             </a:r>
           </a:p>
           <a:p xmlns:a="http://schemas.openxmlformats.org/drawingml/2006/main">
@@ -7672,7 +7672,7 @@
                 <a:ea typeface="Nimbus Sans"/>
                 <a:cs typeface="Nimbus Sans"/>
               </a:rPr>
-              <a:t>Intervalo acima do teto no container; GPU não cronometrada.</a:t>
+              <a:t>Intervalo no teto no notebook (tela de 60 Hz); GPU não cronometrada.</a:t>
             </a:r>
           </a:p>
           <a:p xmlns:a="http://schemas.openxmlformats.org/drawingml/2006/main">
@@ -7809,7 +7809,7 @@
                 <a:ea typeface="Nimbus Sans"/>
                 <a:cs typeface="Nimbus Sans"/>
               </a:rPr>
-              <a:t>ts/src/main.ts; ts/src/bateria/tempo.ts; docs/evidencias/{browser.json, painel-captura.png}</a:t>
+              <a:t>ts/src/main.ts; ts/src/bateria/tempo.ts; docs/evidencias/{medicao-pc.json, medicao-celular.json, painel-pc.png}</a:t>
             </a:r>
           </a:p>
         </p:txBody>

</xml_diff>